<commit_message>
Repair accented typography probe
</commit_message>
<xml_diff>
--- a/tests/Lokad.OoxPdf.Tests/Cases/pptx-ladder-04-typography-accent-spacing-probe.pptx
+++ b/tests/Lokad.OoxPdf.Tests/Cases/pptx-ladder-04-typography-accent-spacing-probe.pptx
@@ -3356,7 +3356,7 @@
               <a:rPr sz="2800">
                 <a:latin typeface="Arial"/>
               </a:rPr>
-              <a:t>DÃ©pendance Ã  l'offre</a:t>
+              <a:t>Dépendance à l'offre</a:t>
             </a:r>
           </a:p>
           <a:p>
@@ -3365,7 +3365,7 @@
               <a:rPr sz="2800">
                 <a:latin typeface="Calibri"/>
               </a:rPr>
-              <a:t>DÃ©pendance Ã©levÃ©e cÃ´tÃ© coÃ»t</a:t>
+              <a:t>Dépendance élevée côté coût</a:t>
             </a:r>
           </a:p>
           <a:p>
@@ -3374,7 +3374,7 @@
               <a:rPr sz="2800">
                 <a:latin typeface="Cambria"/>
               </a:rPr>
-              <a:t>Ã‰cart dÃ©pendance qualitÃ©</a:t>
+              <a:t>Écart dépendance qualité</a:t>
             </a:r>
           </a:p>
           <a:p>
@@ -3383,7 +3383,7 @@
               <a:rPr sz="2800">
                 <a:latin typeface="Arial"/>
               </a:rPr>
-              <a:t>Ã©Ã¨Ãª Ã‰ÃˆÃŠ Ã€Ã‚ Ã‡Ã§</a:t>
+              <a:t>éèê ÉÈÊ ÀÂ Çç</a:t>
             </a:r>
           </a:p>
         </p:txBody>

</xml_diff>